<commit_message>
Apply bigger title-slide branding fix to all decks; add Frayer Model + activity screenshot to W1L2
Matched Arwa's manual resize of the title slide's header/footer
letterhead images (bigger, clearer footer with accreditation badges
and the "Preparing Future Leaders" line) across all three decks. Other
slide types keep the original compact header/footer since they need
the vertical space for content.

W1L2 now also has a Frayer Model slide (Code Editor, extracted from
the vocabulary bank) and a screenshot of the Platform Setup Checklist
on its Lesson Core slide, matching W1L3 and W1L4.

Co-Authored-By: Claude Fable 5 <noreply@anthropic.com>
</commit_message>
<xml_diff>
--- a/resources/week-01/W1L2 - Platform & Login Setup.pptx
+++ b/resources/week-01/W1L2 - Platform & Login Setup.pptx
@@ -14,9 +14,10 @@
     <p:sldId id="262" r:id="rId8"/>
     <p:sldId id="263" r:id="rId9"/>
     <p:sldId id="264" r:id="rId10"/>
+    <p:sldId id="265" r:id="rId11"/>
   </p:sldIdLst>
   <p:notesMasterIdLst>
-    <p:notesMasterId r:id="rId11"/>
+    <p:notesMasterId r:id="rId12"/>
   </p:notesMasterIdLst>
   <p:sldSz cx="9144000" cy="5143500"/>
   <p:notesSz cx="5143500" cy="9144000"/>
@@ -552,6 +553,94 @@
 </p:notes>
 </file>
 
+<file path=ppt/notesSlides/notesSlide10.xml><?xml version="1.0" encoding="utf-8"?>
+<p:notes xmlns:a="http://schemas.openxmlformats.org/drawingml/2006/main" xmlns:r="http://schemas.openxmlformats.org/officeDocument/2006/relationships" xmlns:p="http://schemas.openxmlformats.org/presentationml/2006/main">
+  <p:cSld>
+    <p:spTree>
+      <p:nvGrpSpPr>
+        <p:cNvPr id="1" name=""/>
+        <p:cNvGrpSpPr/>
+        <p:nvPr/>
+      </p:nvGrpSpPr>
+      <p:grpSpPr>
+        <a:xfrm>
+          <a:off x="0" y="0"/>
+          <a:ext cx="0" cy="0"/>
+          <a:chOff x="0" y="0"/>
+          <a:chExt cx="0" cy="0"/>
+        </a:xfrm>
+      </p:grpSpPr>
+      <p:sp>
+        <p:nvSpPr>
+          <p:cNvPr id="2" name="Slide Image Placeholder 1"/>
+          <p:cNvSpPr>
+            <a:spLocks noGrp="1" noRot="1" noChangeAspect="1"/>
+          </p:cNvSpPr>
+          <p:nvPr>
+            <p:ph type="sldImg"/>
+          </p:nvPr>
+        </p:nvSpPr>
+        <p:spPr/>
+      </p:sp>
+      <p:sp>
+        <p:nvSpPr>
+          <p:cNvPr id="3" name="Notes Placeholder 2"/>
+          <p:cNvSpPr>
+            <a:spLocks noGrp="1"/>
+          </p:cNvSpPr>
+          <p:nvPr>
+            <p:ph type="body" idx="1"/>
+          </p:nvPr>
+        </p:nvSpPr>
+        <p:spPr/>
+        <p:txBody>
+          <a:bodyPr/>
+          <a:lstStyle/>
+          <a:p>
+            <a:r>
+              <a:rPr lang="en-US" dirty="0"/>
+              <a:t/>
+            </a:r>
+            <a:endParaRPr lang="en-US" dirty="0"/>
+          </a:p>
+        </p:txBody>
+      </p:sp>
+      <p:sp>
+        <p:nvSpPr>
+          <p:cNvPr id="4" name="Slide Number Placeholder 3"/>
+          <p:cNvSpPr>
+            <a:spLocks noGrp="1"/>
+          </p:cNvSpPr>
+          <p:nvPr>
+            <p:ph type="sldNum" sz="quarter" idx="10"/>
+          </p:nvPr>
+        </p:nvSpPr>
+        <p:spPr/>
+        <p:txBody>
+          <a:bodyPr/>
+          <a:lstStyle/>
+          <a:p>
+            <a:fld id="{F7021451-1387-4CA6-816F-3879F97B5CBC}" type="slidenum">
+              <a:rPr lang="en-US"/>
+              <a:t>10</a:t>
+            </a:fld>
+            <a:endParaRPr lang="en-US"/>
+          </a:p>
+        </p:txBody>
+      </p:sp>
+    </p:spTree>
+    <p:extLst>
+      <p:ext uri="{BB962C8B-B14F-4D97-AF65-F5344CB8AC3E}">
+        <p14:creationId xmlns:p14="http://schemas.microsoft.com/office/powerpoint/2010/main" val="1024086991"/>
+      </p:ext>
+    </p:extLst>
+  </p:cSld>
+  <p:clrMapOvr>
+    <a:masterClrMapping/>
+  </p:clrMapOvr>
+</p:notes>
+</file>
+
 <file path=ppt/notesSlides/notesSlide2.xml><?xml version="1.0" encoding="utf-8"?>
 <p:notes xmlns:a="http://schemas.openxmlformats.org/drawingml/2006/main" xmlns:r="http://schemas.openxmlformats.org/officeDocument/2006/relationships" xmlns:p="http://schemas.openxmlformats.org/presentationml/2006/main">
   <p:cSld>
@@ -1597,7 +1686,7 @@
         <p:spPr>
           <a:xfrm>
             <a:off x="0" y="0"/>
-            <a:ext cx="9144000" cy="960120"/>
+            <a:ext cx="9144000" cy="2074985"/>
           </a:xfrm>
           <a:prstGeom prst="rect">
             <a:avLst/>
@@ -1801,6 +1890,86 @@
         </p:blipFill>
         <p:spPr>
           <a:xfrm>
+            <a:off x="0" y="3487481"/>
+            <a:ext cx="9144000" cy="1656019"/>
+          </a:xfrm>
+          <a:prstGeom prst="rect">
+            <a:avLst/>
+          </a:prstGeom>
+        </p:spPr>
+      </p:pic>
+    </p:spTree>
+  </p:cSld>
+  <p:clrMapOvr>
+    <a:masterClrMapping/>
+  </p:clrMapOvr>
+</p:sld>
+</file>
+
+<file path=ppt/slides/slide10.xml><?xml version="1.0" encoding="utf-8"?>
+<p:sld xmlns:a="http://schemas.openxmlformats.org/drawingml/2006/main" xmlns:r="http://schemas.openxmlformats.org/officeDocument/2006/relationships" xmlns:p="http://schemas.openxmlformats.org/presentationml/2006/main">
+  <p:cSld name="Slide 10">
+    <p:bg>
+      <p:bgPr>
+        <a:solidFill>
+          <a:srgbClr val="FFFFFF"/>
+        </a:solidFill>
+      </p:bgPr>
+    </p:bg>
+    <p:spTree>
+      <p:nvGrpSpPr>
+        <p:cNvPr id="1" name=""/>
+        <p:cNvGrpSpPr/>
+        <p:nvPr/>
+      </p:nvGrpSpPr>
+      <p:grpSpPr>
+        <a:xfrm>
+          <a:off x="0" y="0"/>
+          <a:ext cx="0" cy="0"/>
+          <a:chOff x="0" y="0"/>
+          <a:chExt cx="0" cy="0"/>
+        </a:xfrm>
+      </p:grpSpPr>
+      <p:pic>
+        <p:nvPicPr>
+          <p:cNvPr id="2" name="Image 0" descr="preencoded.png">    </p:cNvPr>
+          <p:cNvPicPr>
+            <a:picLocks noChangeAspect="1"/>
+          </p:cNvPicPr>
+          <p:nvPr/>
+        </p:nvPicPr>
+        <p:blipFill>
+          <a:blip r:embed="rId1"/>
+          <a:stretch>
+            <a:fillRect/>
+          </a:stretch>
+        </p:blipFill>
+        <p:spPr>
+          <a:xfrm>
+            <a:off x="0" y="0"/>
+            <a:ext cx="9144000" cy="960120"/>
+          </a:xfrm>
+          <a:prstGeom prst="rect">
+            <a:avLst/>
+          </a:prstGeom>
+        </p:spPr>
+      </p:pic>
+      <p:pic>
+        <p:nvPicPr>
+          <p:cNvPr id="3" name="Image 1" descr="preencoded.png">    </p:cNvPr>
+          <p:cNvPicPr>
+            <a:picLocks noChangeAspect="1"/>
+          </p:cNvPicPr>
+          <p:nvPr/>
+        </p:nvPicPr>
+        <p:blipFill>
+          <a:blip r:embed="rId2"/>
+          <a:stretch>
+            <a:fillRect/>
+          </a:stretch>
+        </p:blipFill>
+        <p:spPr>
+          <a:xfrm>
             <a:off x="0" y="4576572"/>
             <a:ext cx="9144000" cy="566928"/>
           </a:xfrm>
@@ -1809,6 +1978,246 @@
           </a:prstGeom>
         </p:spPr>
       </p:pic>
+      <p:sp>
+        <p:nvSpPr>
+          <p:cNvPr id="4" name="Shape 0"/>
+          <p:cNvSpPr/>
+          <p:nvPr/>
+        </p:nvSpPr>
+        <p:spPr>
+          <a:xfrm>
+            <a:off x="0" y="960120"/>
+            <a:ext cx="2377440" cy="3616452"/>
+          </a:xfrm>
+          <a:prstGeom prst="rect">
+            <a:avLst/>
+          </a:prstGeom>
+          <a:solidFill>
+            <a:srgbClr val="0F9ED5"/>
+          </a:solidFill>
+          <a:ln w="12700">
+            <a:solidFill>
+              <a:srgbClr val="0F9ED5"/>
+            </a:solidFill>
+            <a:prstDash val="solid"/>
+          </a:ln>
+        </p:spPr>
+      </p:sp>
+      <p:sp>
+        <p:nvSpPr>
+          <p:cNvPr id="5" name="Text 1"/>
+          <p:cNvSpPr/>
+          <p:nvPr/>
+        </p:nvSpPr>
+        <p:spPr>
+          <a:xfrm>
+            <a:off x="0" y="1143000"/>
+            <a:ext cx="2377440" cy="502920"/>
+          </a:xfrm>
+          <a:prstGeom prst="rect">
+            <a:avLst/>
+          </a:prstGeom>
+          <a:noFill/>
+          <a:ln/>
+        </p:spPr>
+        <p:txBody>
+          <a:bodyPr wrap="square" rtlCol="0" anchor="ctr"/>
+          <a:lstStyle/>
+          <a:p>
+            <a:pPr algn="ctr" indent="0" marL="0">
+              <a:buNone/>
+            </a:pPr>
+            <a:r>
+              <a:rPr lang="en-US" sz="1600" b="1" spc="300" kern="0" dirty="0">
+                <a:solidFill>
+                  <a:srgbClr val="FFFFFF"/>
+                </a:solidFill>
+              </a:rPr>
+              <a:t>CLOSURE</a:t>
+            </a:r>
+            <a:endParaRPr lang="en-US" sz="1600" dirty="0"/>
+          </a:p>
+        </p:txBody>
+      </p:sp>
+      <p:sp>
+        <p:nvSpPr>
+          <p:cNvPr id="6" name="Text 2"/>
+          <p:cNvSpPr/>
+          <p:nvPr/>
+        </p:nvSpPr>
+        <p:spPr>
+          <a:xfrm>
+            <a:off x="228600" y="1645920"/>
+            <a:ext cx="1920240" cy="457200"/>
+          </a:xfrm>
+          <a:prstGeom prst="rect">
+            <a:avLst/>
+          </a:prstGeom>
+          <a:noFill/>
+          <a:ln/>
+        </p:spPr>
+        <p:txBody>
+          <a:bodyPr wrap="square" rtlCol="0" anchor="t"/>
+          <a:lstStyle/>
+          <a:p>
+            <a:pPr algn="ctr" indent="0" marL="0">
+              <a:buNone/>
+            </a:pPr>
+            <a:r>
+              <a:rPr lang="en-US" sz="1100" i="1" dirty="0">
+                <a:solidFill>
+                  <a:srgbClr val="CFE8F2"/>
+                </a:solidFill>
+              </a:rPr>
+              <a:t>Transition &amp; Extend</a:t>
+            </a:r>
+            <a:endParaRPr lang="en-US" sz="1100" dirty="0"/>
+          </a:p>
+        </p:txBody>
+      </p:sp>
+      <p:sp>
+        <p:nvSpPr>
+          <p:cNvPr id="7" name="Shape 3"/>
+          <p:cNvSpPr/>
+          <p:nvPr/>
+        </p:nvSpPr>
+        <p:spPr>
+          <a:xfrm>
+            <a:off x="320040" y="2194560"/>
+            <a:ext cx="1737360" cy="0"/>
+          </a:xfrm>
+          <a:prstGeom prst="line">
+            <a:avLst/>
+          </a:prstGeom>
+          <a:noFill/>
+          <a:ln w="9525">
+            <a:solidFill>
+              <a:srgbClr val="FFFFFF">
+                <a:alpha val="60000"/>
+              </a:srgbClr>
+            </a:solidFill>
+            <a:prstDash val="solid"/>
+          </a:ln>
+        </p:spPr>
+      </p:sp>
+      <p:sp>
+        <p:nvSpPr>
+          <p:cNvPr id="8" name="Text 4"/>
+          <p:cNvSpPr/>
+          <p:nvPr/>
+        </p:nvSpPr>
+        <p:spPr>
+          <a:xfrm>
+            <a:off x="228600" y="2331720"/>
+            <a:ext cx="1920240" cy="365760"/>
+          </a:xfrm>
+          <a:prstGeom prst="rect">
+            <a:avLst/>
+          </a:prstGeom>
+          <a:noFill/>
+          <a:ln/>
+        </p:spPr>
+        <p:txBody>
+          <a:bodyPr wrap="square" rtlCol="0" anchor="ctr"/>
+          <a:lstStyle/>
+          <a:p>
+            <a:pPr algn="ctr" indent="0" marL="0">
+              <a:buNone/>
+            </a:pPr>
+            <a:r>
+              <a:rPr lang="en-US" sz="1000" b="1" dirty="0">
+                <a:solidFill>
+                  <a:srgbClr val="CFE8F2"/>
+                </a:solidFill>
+              </a:rPr>
+              <a:t>5 - 10 minutes</a:t>
+            </a:r>
+            <a:endParaRPr lang="en-US" sz="1000" dirty="0"/>
+          </a:p>
+        </p:txBody>
+      </p:sp>
+      <p:sp>
+        <p:nvSpPr>
+          <p:cNvPr id="9" name="Shape 5"/>
+          <p:cNvSpPr/>
+          <p:nvPr/>
+        </p:nvSpPr>
+        <p:spPr>
+          <a:xfrm>
+            <a:off x="2651760" y="1097280"/>
+            <a:ext cx="6217920" cy="3342132"/>
+          </a:xfrm>
+          <a:prstGeom prst="rect">
+            <a:avLst/>
+          </a:prstGeom>
+          <a:solidFill>
+            <a:srgbClr val="EEF6FB"/>
+          </a:solidFill>
+          <a:ln w="12700">
+            <a:solidFill>
+              <a:srgbClr val="D8E4EB"/>
+            </a:solidFill>
+            <a:prstDash val="solid"/>
+          </a:ln>
+        </p:spPr>
+      </p:sp>
+      <p:sp>
+        <p:nvSpPr>
+          <p:cNvPr id="10" name="Text 6"/>
+          <p:cNvSpPr/>
+          <p:nvPr/>
+        </p:nvSpPr>
+        <p:spPr>
+          <a:xfrm>
+            <a:off x="2880360" y="1280160"/>
+            <a:ext cx="5852160" cy="2976372"/>
+          </a:xfrm>
+          <a:prstGeom prst="rect">
+            <a:avLst/>
+          </a:prstGeom>
+          <a:noFill/>
+          <a:ln/>
+        </p:spPr>
+        <p:txBody>
+          <a:bodyPr wrap="square" rtlCol="0" anchor="t"/>
+          <a:lstStyle/>
+          <a:p>
+            <a:pPr marL="342900" indent="-342900">
+              <a:lnSpc>
+                <a:spcPts val="2200"/>
+              </a:lnSpc>
+              <a:buSzPct val="100000"/>
+              <a:buChar char="•"/>
+            </a:pPr>
+            <a:r>
+              <a:rPr lang="en-US" sz="1400" dirty="0">
+                <a:solidFill>
+                  <a:srgbClr val="1A1A1A"/>
+                </a:solidFill>
+              </a:rPr>
+              <a:t>Submit your Hello World screenshot or file link on Toddle.</a:t>
+            </a:r>
+            <a:endParaRPr lang="en-US" sz="1400" dirty="0"/>
+          </a:p>
+          <a:p>
+            <a:pPr indent="0" marL="0">
+              <a:lnSpc>
+                <a:spcPts val="2200"/>
+              </a:lnSpc>
+              <a:buNone/>
+            </a:pPr>
+            <a:r>
+              <a:rPr lang="en-US" sz="1400" dirty="0">
+                <a:solidFill>
+                  <a:srgbClr val="1A1A1A"/>
+                </a:solidFill>
+              </a:rPr>
+              <a:t>This becomes your entry ticket for Lesson 3.</a:t>
+            </a:r>
+            <a:endParaRPr lang="en-US" sz="1400" dirty="0"/>
+          </a:p>
+        </p:txBody>
+      </p:sp>
     </p:spTree>
   </p:cSld>
   <p:clrMapOvr>
@@ -2776,7 +3185,7 @@
                   <a:srgbClr val="FFFFFF"/>
                 </a:solidFill>
               </a:rPr>
-              <a:t>National Identity Integration</a:t>
+              <a:t>Frayer Model: Code Editor</a:t>
             </a:r>
             <a:endParaRPr lang="en-US" sz="1500" dirty="0"/>
           </a:p>
@@ -2790,18 +3199,18 @@
         </p:nvSpPr>
         <p:spPr>
           <a:xfrm>
-            <a:off x="0" y="1453896"/>
-            <a:ext cx="9144000" cy="59436"/>
-          </a:xfrm>
-          <a:prstGeom prst="rect">
-            <a:avLst/>
-          </a:prstGeom>
-          <a:solidFill>
-            <a:srgbClr val="BE0028"/>
-          </a:solidFill>
-          <a:ln w="12700">
+            <a:off x="274320" y="1453896"/>
+            <a:ext cx="4261104" cy="1488186"/>
+          </a:xfrm>
+          <a:prstGeom prst="rect">
+            <a:avLst/>
+          </a:prstGeom>
+          <a:solidFill>
+            <a:srgbClr val="EEF6FB"/>
+          </a:solidFill>
+          <a:ln w="15875">
             <a:solidFill>
-              <a:srgbClr val="BE0028"/>
+              <a:srgbClr val="156082"/>
             </a:solidFill>
             <a:prstDash val="solid"/>
           </a:ln>
@@ -2815,16 +3224,481 @@
         </p:nvSpPr>
         <p:spPr>
           <a:xfrm>
-            <a:off x="0" y="1513332"/>
-            <a:ext cx="9144000" cy="59436"/>
-          </a:xfrm>
-          <a:prstGeom prst="rect">
-            <a:avLst/>
-          </a:prstGeom>
-          <a:solidFill>
-            <a:srgbClr val="FFFFFF"/>
+            <a:off x="274320" y="1453896"/>
+            <a:ext cx="4261104" cy="292608"/>
+          </a:xfrm>
+          <a:prstGeom prst="rect">
+            <a:avLst/>
+          </a:prstGeom>
+          <a:solidFill>
+            <a:srgbClr val="156082"/>
           </a:solidFill>
           <a:ln w="12700">
+            <a:solidFill>
+              <a:srgbClr val="156082"/>
+            </a:solidFill>
+            <a:prstDash val="solid"/>
+          </a:ln>
+        </p:spPr>
+      </p:sp>
+      <p:sp>
+        <p:nvSpPr>
+          <p:cNvPr id="8" name="Text 4"/>
+          <p:cNvSpPr/>
+          <p:nvPr/>
+        </p:nvSpPr>
+        <p:spPr>
+          <a:xfrm>
+            <a:off x="274320" y="1453896"/>
+            <a:ext cx="4261104" cy="292608"/>
+          </a:xfrm>
+          <a:prstGeom prst="rect">
+            <a:avLst/>
+          </a:prstGeom>
+          <a:noFill/>
+          <a:ln/>
+        </p:spPr>
+        <p:txBody>
+          <a:bodyPr wrap="square" lIns="0" tIns="0" rIns="0" bIns="0" rtlCol="0" anchor="ctr"/>
+          <a:lstStyle/>
+          <a:p>
+            <a:pPr algn="ctr" indent="0" marL="0">
+              <a:buNone/>
+            </a:pPr>
+            <a:r>
+              <a:rPr lang="en-US" sz="1050" b="1" spc="100" kern="0" dirty="0">
+                <a:solidFill>
+                  <a:srgbClr val="FFFFFF"/>
+                </a:solidFill>
+              </a:rPr>
+              <a:t>DEFINITION</a:t>
+            </a:r>
+            <a:endParaRPr lang="en-US" sz="1050" dirty="0"/>
+          </a:p>
+        </p:txBody>
+      </p:sp>
+      <p:sp>
+        <p:nvSpPr>
+          <p:cNvPr id="9" name="Text 5"/>
+          <p:cNvSpPr/>
+          <p:nvPr/>
+        </p:nvSpPr>
+        <p:spPr>
+          <a:xfrm>
+            <a:off x="411480" y="1819656"/>
+            <a:ext cx="3986784" cy="1049274"/>
+          </a:xfrm>
+          <a:prstGeom prst="rect">
+            <a:avLst/>
+          </a:prstGeom>
+          <a:noFill/>
+          <a:ln/>
+        </p:spPr>
+        <p:txBody>
+          <a:bodyPr wrap="square" rtlCol="0" anchor="t"/>
+          <a:lstStyle/>
+          <a:p>
+            <a:pPr indent="0" marL="0">
+              <a:buNone/>
+            </a:pPr>
+            <a:r>
+              <a:rPr lang="en-US" sz="1150" dirty="0">
+                <a:solidFill>
+                  <a:srgbClr val="1A1A1A"/>
+                </a:solidFill>
+              </a:rPr>
+              <a:t>A program used to write and save code (for example VS Code or Notepad), different from a word processor because it doesn't add hidden formatting.</a:t>
+            </a:r>
+            <a:endParaRPr lang="en-US" sz="1150" dirty="0"/>
+          </a:p>
+        </p:txBody>
+      </p:sp>
+      <p:sp>
+        <p:nvSpPr>
+          <p:cNvPr id="10" name="Shape 6"/>
+          <p:cNvSpPr/>
+          <p:nvPr/>
+        </p:nvSpPr>
+        <p:spPr>
+          <a:xfrm>
+            <a:off x="4645152" y="1453896"/>
+            <a:ext cx="4261104" cy="1488186"/>
+          </a:xfrm>
+          <a:prstGeom prst="rect">
+            <a:avLst/>
+          </a:prstGeom>
+          <a:solidFill>
+            <a:srgbClr val="EEF6FB"/>
+          </a:solidFill>
+          <a:ln w="15875">
+            <a:solidFill>
+              <a:srgbClr val="0F9ED5"/>
+            </a:solidFill>
+            <a:prstDash val="solid"/>
+          </a:ln>
+        </p:spPr>
+      </p:sp>
+      <p:sp>
+        <p:nvSpPr>
+          <p:cNvPr id="11" name="Shape 7"/>
+          <p:cNvSpPr/>
+          <p:nvPr/>
+        </p:nvSpPr>
+        <p:spPr>
+          <a:xfrm>
+            <a:off x="4645152" y="1453896"/>
+            <a:ext cx="4261104" cy="292608"/>
+          </a:xfrm>
+          <a:prstGeom prst="rect">
+            <a:avLst/>
+          </a:prstGeom>
+          <a:solidFill>
+            <a:srgbClr val="0F9ED5"/>
+          </a:solidFill>
+          <a:ln w="12700">
+            <a:solidFill>
+              <a:srgbClr val="0F9ED5"/>
+            </a:solidFill>
+            <a:prstDash val="solid"/>
+          </a:ln>
+        </p:spPr>
+      </p:sp>
+      <p:sp>
+        <p:nvSpPr>
+          <p:cNvPr id="12" name="Text 8"/>
+          <p:cNvSpPr/>
+          <p:nvPr/>
+        </p:nvSpPr>
+        <p:spPr>
+          <a:xfrm>
+            <a:off x="4645152" y="1453896"/>
+            <a:ext cx="4261104" cy="292608"/>
+          </a:xfrm>
+          <a:prstGeom prst="rect">
+            <a:avLst/>
+          </a:prstGeom>
+          <a:noFill/>
+          <a:ln/>
+        </p:spPr>
+        <p:txBody>
+          <a:bodyPr wrap="square" lIns="0" tIns="0" rIns="0" bIns="0" rtlCol="0" anchor="ctr"/>
+          <a:lstStyle/>
+          <a:p>
+            <a:pPr algn="ctr" indent="0" marL="0">
+              <a:buNone/>
+            </a:pPr>
+            <a:r>
+              <a:rPr lang="en-US" sz="1050" b="1" spc="100" kern="0" dirty="0">
+                <a:solidFill>
+                  <a:srgbClr val="FFFFFF"/>
+                </a:solidFill>
+              </a:rPr>
+              <a:t>CHARACTERISTICS</a:t>
+            </a:r>
+            <a:endParaRPr lang="en-US" sz="1050" dirty="0"/>
+          </a:p>
+        </p:txBody>
+      </p:sp>
+      <p:sp>
+        <p:nvSpPr>
+          <p:cNvPr id="13" name="Text 9"/>
+          <p:cNvSpPr/>
+          <p:nvPr/>
+        </p:nvSpPr>
+        <p:spPr>
+          <a:xfrm>
+            <a:off x="4782312" y="1819656"/>
+            <a:ext cx="3986784" cy="1049274"/>
+          </a:xfrm>
+          <a:prstGeom prst="rect">
+            <a:avLst/>
+          </a:prstGeom>
+          <a:noFill/>
+          <a:ln/>
+        </p:spPr>
+        <p:txBody>
+          <a:bodyPr wrap="square" rtlCol="0" anchor="t"/>
+          <a:lstStyle/>
+          <a:p>
+            <a:pPr indent="0" marL="0">
+              <a:buNone/>
+            </a:pPr>
+            <a:r>
+              <a:rPr lang="en-US" sz="1150" dirty="0">
+                <a:solidFill>
+                  <a:srgbClr val="1A1A1A"/>
+                </a:solidFill>
+              </a:rPr>
+              <a:t>Highlights code by color. Shows line numbers. No hidden formatting.</a:t>
+            </a:r>
+            <a:endParaRPr lang="en-US" sz="1150" dirty="0"/>
+          </a:p>
+        </p:txBody>
+      </p:sp>
+      <p:sp>
+        <p:nvSpPr>
+          <p:cNvPr id="14" name="Shape 10"/>
+          <p:cNvSpPr/>
+          <p:nvPr/>
+        </p:nvSpPr>
+        <p:spPr>
+          <a:xfrm>
+            <a:off x="274320" y="3051810"/>
+            <a:ext cx="4261104" cy="1488186"/>
+          </a:xfrm>
+          <a:prstGeom prst="rect">
+            <a:avLst/>
+          </a:prstGeom>
+          <a:solidFill>
+            <a:srgbClr val="EEF6FB"/>
+          </a:solidFill>
+          <a:ln w="15875">
+            <a:solidFill>
+              <a:srgbClr val="0E2841"/>
+            </a:solidFill>
+            <a:prstDash val="solid"/>
+          </a:ln>
+        </p:spPr>
+      </p:sp>
+      <p:sp>
+        <p:nvSpPr>
+          <p:cNvPr id="15" name="Shape 11"/>
+          <p:cNvSpPr/>
+          <p:nvPr/>
+        </p:nvSpPr>
+        <p:spPr>
+          <a:xfrm>
+            <a:off x="274320" y="3051810"/>
+            <a:ext cx="4261104" cy="292608"/>
+          </a:xfrm>
+          <a:prstGeom prst="rect">
+            <a:avLst/>
+          </a:prstGeom>
+          <a:solidFill>
+            <a:srgbClr val="0E2841"/>
+          </a:solidFill>
+          <a:ln w="12700">
+            <a:solidFill>
+              <a:srgbClr val="0E2841"/>
+            </a:solidFill>
+            <a:prstDash val="solid"/>
+          </a:ln>
+        </p:spPr>
+      </p:sp>
+      <p:sp>
+        <p:nvSpPr>
+          <p:cNvPr id="16" name="Text 12"/>
+          <p:cNvSpPr/>
+          <p:nvPr/>
+        </p:nvSpPr>
+        <p:spPr>
+          <a:xfrm>
+            <a:off x="274320" y="3051810"/>
+            <a:ext cx="4261104" cy="292608"/>
+          </a:xfrm>
+          <a:prstGeom prst="rect">
+            <a:avLst/>
+          </a:prstGeom>
+          <a:noFill/>
+          <a:ln/>
+        </p:spPr>
+        <p:txBody>
+          <a:bodyPr wrap="square" lIns="0" tIns="0" rIns="0" bIns="0" rtlCol="0" anchor="ctr"/>
+          <a:lstStyle/>
+          <a:p>
+            <a:pPr algn="ctr" indent="0" marL="0">
+              <a:buNone/>
+            </a:pPr>
+            <a:r>
+              <a:rPr lang="en-US" sz="1050" b="1" spc="100" kern="0" dirty="0">
+                <a:solidFill>
+                  <a:srgbClr val="FFFFFF"/>
+                </a:solidFill>
+              </a:rPr>
+              <a:t>EXAMPLES</a:t>
+            </a:r>
+            <a:endParaRPr lang="en-US" sz="1050" dirty="0"/>
+          </a:p>
+        </p:txBody>
+      </p:sp>
+      <p:sp>
+        <p:nvSpPr>
+          <p:cNvPr id="17" name="Text 13"/>
+          <p:cNvSpPr/>
+          <p:nvPr/>
+        </p:nvSpPr>
+        <p:spPr>
+          <a:xfrm>
+            <a:off x="411480" y="3417570"/>
+            <a:ext cx="3986784" cy="1049274"/>
+          </a:xfrm>
+          <a:prstGeom prst="rect">
+            <a:avLst/>
+          </a:prstGeom>
+          <a:noFill/>
+          <a:ln/>
+        </p:spPr>
+        <p:txBody>
+          <a:bodyPr wrap="square" rtlCol="0" anchor="t"/>
+          <a:lstStyle/>
+          <a:p>
+            <a:pPr indent="0" marL="0">
+              <a:buNone/>
+            </a:pPr>
+            <a:r>
+              <a:rPr lang="en-US" sz="1150" dirty="0">
+                <a:solidFill>
+                  <a:srgbClr val="1A1A1A"/>
+                </a:solidFill>
+              </a:rPr>
+              <a:t>VS Code. Notepad. Sublime Text.</a:t>
+            </a:r>
+            <a:endParaRPr lang="en-US" sz="1150" dirty="0"/>
+          </a:p>
+        </p:txBody>
+      </p:sp>
+      <p:sp>
+        <p:nvSpPr>
+          <p:cNvPr id="18" name="Shape 14"/>
+          <p:cNvSpPr/>
+          <p:nvPr/>
+        </p:nvSpPr>
+        <p:spPr>
+          <a:xfrm>
+            <a:off x="4645152" y="3051810"/>
+            <a:ext cx="4261104" cy="1488186"/>
+          </a:xfrm>
+          <a:prstGeom prst="rect">
+            <a:avLst/>
+          </a:prstGeom>
+          <a:solidFill>
+            <a:srgbClr val="EEF6FB"/>
+          </a:solidFill>
+          <a:ln w="15875">
+            <a:solidFill>
+              <a:srgbClr val="B45309"/>
+            </a:solidFill>
+            <a:prstDash val="solid"/>
+          </a:ln>
+        </p:spPr>
+      </p:sp>
+      <p:sp>
+        <p:nvSpPr>
+          <p:cNvPr id="19" name="Shape 15"/>
+          <p:cNvSpPr/>
+          <p:nvPr/>
+        </p:nvSpPr>
+        <p:spPr>
+          <a:xfrm>
+            <a:off x="4645152" y="3051810"/>
+            <a:ext cx="4261104" cy="292608"/>
+          </a:xfrm>
+          <a:prstGeom prst="rect">
+            <a:avLst/>
+          </a:prstGeom>
+          <a:solidFill>
+            <a:srgbClr val="B45309"/>
+          </a:solidFill>
+          <a:ln w="12700">
+            <a:solidFill>
+              <a:srgbClr val="B45309"/>
+            </a:solidFill>
+            <a:prstDash val="solid"/>
+          </a:ln>
+        </p:spPr>
+      </p:sp>
+      <p:sp>
+        <p:nvSpPr>
+          <p:cNvPr id="20" name="Text 16"/>
+          <p:cNvSpPr/>
+          <p:nvPr/>
+        </p:nvSpPr>
+        <p:spPr>
+          <a:xfrm>
+            <a:off x="4645152" y="3051810"/>
+            <a:ext cx="4261104" cy="292608"/>
+          </a:xfrm>
+          <a:prstGeom prst="rect">
+            <a:avLst/>
+          </a:prstGeom>
+          <a:noFill/>
+          <a:ln/>
+        </p:spPr>
+        <p:txBody>
+          <a:bodyPr wrap="square" lIns="0" tIns="0" rIns="0" bIns="0" rtlCol="0" anchor="ctr"/>
+          <a:lstStyle/>
+          <a:p>
+            <a:pPr algn="ctr" indent="0" marL="0">
+              <a:buNone/>
+            </a:pPr>
+            <a:r>
+              <a:rPr lang="en-US" sz="1050" b="1" spc="100" kern="0" dirty="0">
+                <a:solidFill>
+                  <a:srgbClr val="FFFFFF"/>
+                </a:solidFill>
+              </a:rPr>
+              <a:t>NON-EXAMPLES</a:t>
+            </a:r>
+            <a:endParaRPr lang="en-US" sz="1050" dirty="0"/>
+          </a:p>
+        </p:txBody>
+      </p:sp>
+      <p:sp>
+        <p:nvSpPr>
+          <p:cNvPr id="21" name="Text 17"/>
+          <p:cNvSpPr/>
+          <p:nvPr/>
+        </p:nvSpPr>
+        <p:spPr>
+          <a:xfrm>
+            <a:off x="4782312" y="3417570"/>
+            <a:ext cx="3986784" cy="1049274"/>
+          </a:xfrm>
+          <a:prstGeom prst="rect">
+            <a:avLst/>
+          </a:prstGeom>
+          <a:noFill/>
+          <a:ln/>
+        </p:spPr>
+        <p:txBody>
+          <a:bodyPr wrap="square" rtlCol="0" anchor="t"/>
+          <a:lstStyle/>
+          <a:p>
+            <a:pPr indent="0" marL="0">
+              <a:buNone/>
+            </a:pPr>
+            <a:r>
+              <a:rPr lang="en-US" sz="1150" dirty="0">
+                <a:solidFill>
+                  <a:srgbClr val="1A1A1A"/>
+                </a:solidFill>
+              </a:rPr>
+              <a:t>Microsoft Word. A web browser.</a:t>
+            </a:r>
+            <a:endParaRPr lang="en-US" sz="1150" dirty="0"/>
+          </a:p>
+        </p:txBody>
+      </p:sp>
+      <p:sp>
+        <p:nvSpPr>
+          <p:cNvPr id="22" name="Shape 18"/>
+          <p:cNvSpPr/>
+          <p:nvPr/>
+        </p:nvSpPr>
+        <p:spPr>
+          <a:xfrm>
+            <a:off x="3794760" y="2727198"/>
+            <a:ext cx="1554480" cy="502920"/>
+          </a:xfrm>
+          <a:prstGeom prst="roundRect">
+            <a:avLst>
+              <a:gd name="adj" fmla="val 18182"/>
+            </a:avLst>
+          </a:prstGeom>
+          <a:solidFill>
+            <a:srgbClr val="0E2841"/>
+          </a:solidFill>
+          <a:ln w="25400">
             <a:solidFill>
               <a:srgbClr val="FFFFFF"/>
             </a:solidFill>
@@ -2834,114 +3708,14 @@
       </p:sp>
       <p:sp>
         <p:nvSpPr>
-          <p:cNvPr id="8" name="Shape 4"/>
-          <p:cNvSpPr/>
-          <p:nvPr/>
-        </p:nvSpPr>
-        <p:spPr>
-          <a:xfrm>
-            <a:off x="0" y="1572768"/>
-            <a:ext cx="9144000" cy="59436"/>
-          </a:xfrm>
-          <a:prstGeom prst="rect">
-            <a:avLst/>
-          </a:prstGeom>
-          <a:solidFill>
-            <a:srgbClr val="1A1A1A"/>
-          </a:solidFill>
-          <a:ln w="12700">
-            <a:solidFill>
-              <a:srgbClr val="1A1A1A"/>
-            </a:solidFill>
-            <a:prstDash val="solid"/>
-          </a:ln>
-        </p:spPr>
-      </p:sp>
-      <p:sp>
-        <p:nvSpPr>
-          <p:cNvPr id="9" name="Shape 5"/>
-          <p:cNvSpPr/>
-          <p:nvPr/>
-        </p:nvSpPr>
-        <p:spPr>
-          <a:xfrm>
-            <a:off x="0" y="1632204"/>
-            <a:ext cx="9144000" cy="59436"/>
-          </a:xfrm>
-          <a:prstGeom prst="rect">
-            <a:avLst/>
-          </a:prstGeom>
-          <a:solidFill>
-            <a:srgbClr val="00843D"/>
-          </a:solidFill>
-          <a:ln w="12700">
-            <a:solidFill>
-              <a:srgbClr val="00843D"/>
-            </a:solidFill>
-            <a:prstDash val="solid"/>
-          </a:ln>
-        </p:spPr>
-      </p:sp>
-      <p:sp>
-        <p:nvSpPr>
-          <p:cNvPr id="10" name="Shape 6"/>
-          <p:cNvSpPr/>
-          <p:nvPr/>
-        </p:nvSpPr>
-        <p:spPr>
-          <a:xfrm>
-            <a:off x="274320" y="1773936"/>
-            <a:ext cx="8595360" cy="2702052"/>
-          </a:xfrm>
-          <a:prstGeom prst="rect">
-            <a:avLst/>
-          </a:prstGeom>
-          <a:solidFill>
-            <a:srgbClr val="EEF6FB"/>
-          </a:solidFill>
-          <a:ln w="12700">
-            <a:solidFill>
-              <a:srgbClr val="D8E4EB"/>
-            </a:solidFill>
-            <a:prstDash val="solid"/>
-          </a:ln>
-        </p:spPr>
-      </p:sp>
-      <p:sp>
-        <p:nvSpPr>
-          <p:cNvPr id="11" name="Shape 7"/>
-          <p:cNvSpPr/>
-          <p:nvPr/>
-        </p:nvSpPr>
-        <p:spPr>
-          <a:xfrm>
-            <a:off x="274320" y="1773936"/>
-            <a:ext cx="64008" cy="2702052"/>
-          </a:xfrm>
-          <a:prstGeom prst="rect">
-            <a:avLst/>
-          </a:prstGeom>
-          <a:solidFill>
-            <a:srgbClr val="BE0028"/>
-          </a:solidFill>
-          <a:ln w="12700">
-            <a:solidFill>
-              <a:srgbClr val="BE0028"/>
-            </a:solidFill>
-            <a:prstDash val="solid"/>
-          </a:ln>
-        </p:spPr>
-      </p:sp>
-      <p:sp>
-        <p:nvSpPr>
-          <p:cNvPr id="12" name="Text 8"/>
-          <p:cNvSpPr/>
-          <p:nvPr/>
-        </p:nvSpPr>
-        <p:spPr>
-          <a:xfrm>
-            <a:off x="502920" y="1865376"/>
-            <a:ext cx="8321040" cy="2500884"/>
+          <p:cNvPr id="23" name="Text 19"/>
+          <p:cNvSpPr/>
+          <p:nvPr/>
+        </p:nvSpPr>
+        <p:spPr>
+          <a:xfrm>
+            <a:off x="3794760" y="2727198"/>
+            <a:ext cx="1554480" cy="502920"/>
           </a:xfrm>
           <a:prstGeom prst="rect">
             <a:avLst/>
@@ -2950,19 +3724,19 @@
           <a:ln/>
         </p:spPr>
         <p:txBody>
-          <a:bodyPr wrap="square" rtlCol="0" anchor="t"/>
-          <a:lstStyle/>
-          <a:p>
-            <a:pPr indent="0" marL="0">
+          <a:bodyPr wrap="square" lIns="0" tIns="0" rIns="0" bIns="0" rtlCol="0" anchor="ctr"/>
+          <a:lstStyle/>
+          <a:p>
+            <a:pPr algn="ctr" indent="0" marL="0">
               <a:buNone/>
             </a:pPr>
             <a:r>
-              <a:rPr lang="en-US" sz="1300" dirty="0">
-                <a:solidFill>
-                  <a:srgbClr val="1A1A1A"/>
-                </a:solidFill>
-              </a:rPr>
-              <a:t>UAE Digital Transformation and Future Skills: as you learn to build for the web this term, you're practicing exactly the kind of digital skill the UAE is investing in as it builds a future economy powered by technology and innovation.</a:t>
+              <a:rPr lang="en-US" sz="1300" b="1" dirty="0">
+                <a:solidFill>
+                  <a:srgbClr val="FFFFFF"/>
+                </a:solidFill>
+              </a:rPr>
+              <a:t>CODE EDITOR</a:t>
             </a:r>
             <a:endParaRPr lang="en-US" sz="1300" dirty="0"/>
           </a:p>
@@ -3057,7 +3831,7 @@
         <p:spPr>
           <a:xfrm>
             <a:off x="0" y="960120"/>
-            <a:ext cx="2377440" cy="3616452"/>
+            <a:ext cx="9144000" cy="384048"/>
           </a:xfrm>
           <a:prstGeom prst="rect">
             <a:avLst/>
@@ -3081,8 +3855,8 @@
         </p:nvSpPr>
         <p:spPr>
           <a:xfrm>
-            <a:off x="0" y="1143000"/>
-            <a:ext cx="2377440" cy="502920"/>
+            <a:off x="320040" y="960120"/>
+            <a:ext cx="8503920" cy="384048"/>
           </a:xfrm>
           <a:prstGeom prst="rect">
             <a:avLst/>
@@ -3091,80 +3865,44 @@
           <a:ln/>
         </p:spPr>
         <p:txBody>
-          <a:bodyPr wrap="square" rtlCol="0" anchor="ctr"/>
-          <a:lstStyle/>
-          <a:p>
-            <a:pPr algn="ctr" indent="0" marL="0">
+          <a:bodyPr wrap="square" lIns="0" tIns="0" rIns="0" bIns="0" rtlCol="0" anchor="ctr"/>
+          <a:lstStyle/>
+          <a:p>
+            <a:pPr indent="0" marL="0">
               <a:buNone/>
             </a:pPr>
             <a:r>
-              <a:rPr lang="en-US" sz="1600" b="1" spc="300" kern="0" dirty="0">
+              <a:rPr lang="en-US" sz="1500" b="1" dirty="0">
                 <a:solidFill>
                   <a:srgbClr val="FFFFFF"/>
                 </a:solidFill>
               </a:rPr>
-              <a:t>STARTER</a:t>
-            </a:r>
-            <a:endParaRPr lang="en-US" sz="1600" dirty="0"/>
-          </a:p>
-        </p:txBody>
-      </p:sp>
-      <p:sp>
-        <p:nvSpPr>
-          <p:cNvPr id="6" name="Text 2"/>
-          <p:cNvSpPr/>
-          <p:nvPr/>
-        </p:nvSpPr>
-        <p:spPr>
-          <a:xfrm>
-            <a:off x="228600" y="1645920"/>
-            <a:ext cx="1920240" cy="457200"/>
-          </a:xfrm>
-          <a:prstGeom prst="rect">
-            <a:avLst/>
-          </a:prstGeom>
-          <a:noFill/>
-          <a:ln/>
-        </p:spPr>
-        <p:txBody>
-          <a:bodyPr wrap="square" rtlCol="0" anchor="t"/>
-          <a:lstStyle/>
-          <a:p>
-            <a:pPr algn="ctr" indent="0" marL="0">
-              <a:buNone/>
-            </a:pPr>
-            <a:r>
-              <a:rPr lang="en-US" sz="1100" i="1" dirty="0">
-                <a:solidFill>
-                  <a:srgbClr val="CFE8F2"/>
-                </a:solidFill>
-              </a:rPr>
-              <a:t>Hook - Engage &amp; Ask</a:t>
-            </a:r>
-            <a:endParaRPr lang="en-US" sz="1100" dirty="0"/>
-          </a:p>
-        </p:txBody>
-      </p:sp>
-      <p:sp>
-        <p:nvSpPr>
-          <p:cNvPr id="7" name="Shape 3"/>
-          <p:cNvSpPr/>
-          <p:nvPr/>
-        </p:nvSpPr>
-        <p:spPr>
-          <a:xfrm>
-            <a:off x="320040" y="2194560"/>
-            <a:ext cx="1737360" cy="0"/>
-          </a:xfrm>
-          <a:prstGeom prst="line">
-            <a:avLst/>
-          </a:prstGeom>
-          <a:noFill/>
-          <a:ln w="9525">
+              <a:t>National Identity Integration</a:t>
+            </a:r>
+            <a:endParaRPr lang="en-US" sz="1500" dirty="0"/>
+          </a:p>
+        </p:txBody>
+      </p:sp>
+      <p:sp>
+        <p:nvSpPr>
+          <p:cNvPr id="6" name="Shape 2"/>
+          <p:cNvSpPr/>
+          <p:nvPr/>
+        </p:nvSpPr>
+        <p:spPr>
+          <a:xfrm>
+            <a:off x="0" y="1453896"/>
+            <a:ext cx="9144000" cy="59436"/>
+          </a:xfrm>
+          <a:prstGeom prst="rect">
+            <a:avLst/>
+          </a:prstGeom>
+          <a:solidFill>
+            <a:srgbClr val="BE0028"/>
+          </a:solidFill>
+          <a:ln w="12700">
             <a:solidFill>
-              <a:srgbClr val="FFFFFF">
-                <a:alpha val="60000"/>
-              </a:srgbClr>
+              <a:srgbClr val="BE0028"/>
             </a:solidFill>
             <a:prstDash val="solid"/>
           </a:ln>
@@ -3172,39 +3910,53 @@
       </p:sp>
       <p:sp>
         <p:nvSpPr>
-          <p:cNvPr id="8" name="Text 4"/>
-          <p:cNvSpPr/>
-          <p:nvPr/>
-        </p:nvSpPr>
-        <p:spPr>
-          <a:xfrm>
-            <a:off x="228600" y="2331720"/>
-            <a:ext cx="1920240" cy="365760"/>
-          </a:xfrm>
-          <a:prstGeom prst="rect">
-            <a:avLst/>
-          </a:prstGeom>
-          <a:noFill/>
-          <a:ln/>
-        </p:spPr>
-        <p:txBody>
-          <a:bodyPr wrap="square" rtlCol="0" anchor="ctr"/>
-          <a:lstStyle/>
-          <a:p>
-            <a:pPr algn="ctr" indent="0" marL="0">
-              <a:buNone/>
-            </a:pPr>
-            <a:r>
-              <a:rPr lang="en-US" sz="1000" b="1" dirty="0">
-                <a:solidFill>
-                  <a:srgbClr val="CFE8F2"/>
-                </a:solidFill>
-              </a:rPr>
-              <a:t>5 - 10 minutes</a:t>
-            </a:r>
-            <a:endParaRPr lang="en-US" sz="1000" dirty="0"/>
-          </a:p>
-        </p:txBody>
+          <p:cNvPr id="7" name="Shape 3"/>
+          <p:cNvSpPr/>
+          <p:nvPr/>
+        </p:nvSpPr>
+        <p:spPr>
+          <a:xfrm>
+            <a:off x="0" y="1513332"/>
+            <a:ext cx="9144000" cy="59436"/>
+          </a:xfrm>
+          <a:prstGeom prst="rect">
+            <a:avLst/>
+          </a:prstGeom>
+          <a:solidFill>
+            <a:srgbClr val="FFFFFF"/>
+          </a:solidFill>
+          <a:ln w="12700">
+            <a:solidFill>
+              <a:srgbClr val="FFFFFF"/>
+            </a:solidFill>
+            <a:prstDash val="solid"/>
+          </a:ln>
+        </p:spPr>
+      </p:sp>
+      <p:sp>
+        <p:nvSpPr>
+          <p:cNvPr id="8" name="Shape 4"/>
+          <p:cNvSpPr/>
+          <p:nvPr/>
+        </p:nvSpPr>
+        <p:spPr>
+          <a:xfrm>
+            <a:off x="0" y="1572768"/>
+            <a:ext cx="9144000" cy="59436"/>
+          </a:xfrm>
+          <a:prstGeom prst="rect">
+            <a:avLst/>
+          </a:prstGeom>
+          <a:solidFill>
+            <a:srgbClr val="1A1A1A"/>
+          </a:solidFill>
+          <a:ln w="12700">
+            <a:solidFill>
+              <a:srgbClr val="1A1A1A"/>
+            </a:solidFill>
+            <a:prstDash val="solid"/>
+          </a:ln>
+        </p:spPr>
       </p:sp>
       <p:sp>
         <p:nvSpPr>
@@ -3214,8 +3966,33 @@
         </p:nvSpPr>
         <p:spPr>
           <a:xfrm>
-            <a:off x="2651760" y="1097280"/>
-            <a:ext cx="6217920" cy="3342132"/>
+            <a:off x="0" y="1632204"/>
+            <a:ext cx="9144000" cy="59436"/>
+          </a:xfrm>
+          <a:prstGeom prst="rect">
+            <a:avLst/>
+          </a:prstGeom>
+          <a:solidFill>
+            <a:srgbClr val="00843D"/>
+          </a:solidFill>
+          <a:ln w="12700">
+            <a:solidFill>
+              <a:srgbClr val="00843D"/>
+            </a:solidFill>
+            <a:prstDash val="solid"/>
+          </a:ln>
+        </p:spPr>
+      </p:sp>
+      <p:sp>
+        <p:nvSpPr>
+          <p:cNvPr id="10" name="Shape 6"/>
+          <p:cNvSpPr/>
+          <p:nvPr/>
+        </p:nvSpPr>
+        <p:spPr>
+          <a:xfrm>
+            <a:off x="274320" y="1773936"/>
+            <a:ext cx="8595360" cy="2702052"/>
           </a:xfrm>
           <a:prstGeom prst="rect">
             <a:avLst/>
@@ -3233,14 +4010,39 @@
       </p:sp>
       <p:sp>
         <p:nvSpPr>
-          <p:cNvPr id="10" name="Text 6"/>
-          <p:cNvSpPr/>
-          <p:nvPr/>
-        </p:nvSpPr>
-        <p:spPr>
-          <a:xfrm>
-            <a:off x="2880360" y="1280160"/>
-            <a:ext cx="5852160" cy="2976372"/>
+          <p:cNvPr id="11" name="Shape 7"/>
+          <p:cNvSpPr/>
+          <p:nvPr/>
+        </p:nvSpPr>
+        <p:spPr>
+          <a:xfrm>
+            <a:off x="274320" y="1773936"/>
+            <a:ext cx="64008" cy="2702052"/>
+          </a:xfrm>
+          <a:prstGeom prst="rect">
+            <a:avLst/>
+          </a:prstGeom>
+          <a:solidFill>
+            <a:srgbClr val="BE0028"/>
+          </a:solidFill>
+          <a:ln w="12700">
+            <a:solidFill>
+              <a:srgbClr val="BE0028"/>
+            </a:solidFill>
+            <a:prstDash val="solid"/>
+          </a:ln>
+        </p:spPr>
+      </p:sp>
+      <p:sp>
+        <p:nvSpPr>
+          <p:cNvPr id="12" name="Text 8"/>
+          <p:cNvSpPr/>
+          <p:nvPr/>
+        </p:nvSpPr>
+        <p:spPr>
+          <a:xfrm>
+            <a:off x="502920" y="1865376"/>
+            <a:ext cx="8321040" cy="2500884"/>
           </a:xfrm>
           <a:prstGeom prst="rect">
             <a:avLst/>
@@ -3252,39 +4054,18 @@
           <a:bodyPr wrap="square" rtlCol="0" anchor="t"/>
           <a:lstStyle/>
           <a:p>
-            <a:pPr marL="342900" indent="-342900">
-              <a:lnSpc>
-                <a:spcPts val="2200"/>
-              </a:lnSpc>
-              <a:buSzPct val="100000"/>
-              <a:buChar char="•"/>
-            </a:pPr>
-            <a:r>
-              <a:rPr lang="en-US" sz="1400" dirty="0">
+            <a:pPr indent="0" marL="0">
+              <a:buNone/>
+            </a:pPr>
+            <a:r>
+              <a:rPr lang="en-US" sz="1300" dirty="0">
                 <a:solidFill>
                   <a:srgbClr val="1A1A1A"/>
                 </a:solidFill>
               </a:rPr>
-              <a:t>Quick show of hands: who has written any HTML or code before?</a:t>
-            </a:r>
-            <a:endParaRPr lang="en-US" sz="1400" dirty="0"/>
-          </a:p>
-          <a:p>
-            <a:pPr indent="0" marL="0">
-              <a:lnSpc>
-                <a:spcPts val="2200"/>
-              </a:lnSpc>
-              <a:buNone/>
-            </a:pPr>
-            <a:r>
-              <a:rPr lang="en-US" sz="1400" dirty="0">
-                <a:solidFill>
-                  <a:srgbClr val="1A1A1A"/>
-                </a:solidFill>
-              </a:rPr>
-              <a:t>Let's see where the room is at.</a:t>
-            </a:r>
-            <a:endParaRPr lang="en-US" sz="1400" dirty="0"/>
+              <a:t>UAE Digital Transformation and Future Skills: as you learn to build for the web this term, you're practicing exactly the kind of digital skill the UAE is investing in as it builds a future economy powered by technology and innovation.</a:t>
+            </a:r>
+            <a:endParaRPr lang="en-US" sz="1300" dirty="0"/>
           </a:p>
         </p:txBody>
       </p:sp>
@@ -3383,11 +4164,11 @@
             <a:avLst/>
           </a:prstGeom>
           <a:solidFill>
-            <a:srgbClr val="0E2841"/>
+            <a:srgbClr val="156082"/>
           </a:solidFill>
           <a:ln w="12700">
             <a:solidFill>
-              <a:srgbClr val="0E2841"/>
+              <a:srgbClr val="156082"/>
             </a:solidFill>
             <a:prstDash val="solid"/>
           </a:ln>
@@ -3423,7 +4204,7 @@
                   <a:srgbClr val="FFFFFF"/>
                 </a:solidFill>
               </a:rPr>
-              <a:t>LESSON CORE</a:t>
+              <a:t>STARTER</a:t>
             </a:r>
             <a:endParaRPr lang="en-US" sz="1600" dirty="0"/>
           </a:p>
@@ -3459,7 +4240,7 @@
                   <a:srgbClr val="CFE8F2"/>
                 </a:solidFill>
               </a:rPr>
-              <a:t>Gradual Release of Responsibility</a:t>
+              <a:t>Hook - Engage &amp; Ask</a:t>
             </a:r>
             <a:endParaRPr lang="en-US" sz="1100" dirty="0"/>
           </a:p>
@@ -3520,7 +4301,7 @@
                   <a:srgbClr val="CFE8F2"/>
                 </a:solidFill>
               </a:rPr>
-              <a:t>30 - 40 minutes</a:t>
+              <a:t>5 - 10 minutes</a:t>
             </a:r>
             <a:endParaRPr lang="en-US" sz="1000" dirty="0"/>
           </a:p>
@@ -3528,43 +4309,7 @@
       </p:sp>
       <p:sp>
         <p:nvSpPr>
-          <p:cNvPr id="9" name="Text 5"/>
-          <p:cNvSpPr/>
-          <p:nvPr/>
-        </p:nvSpPr>
-        <p:spPr>
-          <a:xfrm>
-            <a:off x="228600" y="4119372"/>
-            <a:ext cx="1920240" cy="320040"/>
-          </a:xfrm>
-          <a:prstGeom prst="rect">
-            <a:avLst/>
-          </a:prstGeom>
-          <a:noFill/>
-          <a:ln/>
-        </p:spPr>
-        <p:txBody>
-          <a:bodyPr wrap="square" rtlCol="0" anchor="ctr"/>
-          <a:lstStyle/>
-          <a:p>
-            <a:pPr algn="ctr" indent="0" marL="0">
-              <a:buNone/>
-            </a:pPr>
-            <a:r>
-              <a:rPr lang="en-US" sz="1000" dirty="0">
-                <a:solidFill>
-                  <a:srgbClr val="CFE8F2"/>
-                </a:solidFill>
-              </a:rPr>
-              <a:t>1 / 3</a:t>
-            </a:r>
-            <a:endParaRPr lang="en-US" sz="1000" dirty="0"/>
-          </a:p>
-        </p:txBody>
-      </p:sp>
-      <p:sp>
-        <p:nvSpPr>
-          <p:cNvPr id="10" name="Shape 6"/>
+          <p:cNvPr id="9" name="Shape 5"/>
           <p:cNvSpPr/>
           <p:nvPr/>
         </p:nvSpPr>
@@ -3589,7 +4334,7 @@
       </p:sp>
       <p:sp>
         <p:nvSpPr>
-          <p:cNvPr id="11" name="Text 7"/>
+          <p:cNvPr id="10" name="Text 6"/>
           <p:cNvSpPr/>
           <p:nvPr/>
         </p:nvSpPr>
@@ -3621,7 +4366,7 @@
                   <a:srgbClr val="1A1A1A"/>
                 </a:solidFill>
               </a:rPr>
-              <a:t>Getting Connected</a:t>
+              <a:t>Quick show of hands: who has written any HTML or code before?</a:t>
             </a:r>
             <a:endParaRPr lang="en-US" sz="1400" dirty="0"/>
           </a:p>
@@ -3638,24 +4383,7 @@
                   <a:srgbClr val="1A1A1A"/>
                 </a:solidFill>
               </a:rPr>
-              <a:t>Log into your laptop and check the school network.</a:t>
-            </a:r>
-            <a:endParaRPr lang="en-US" sz="1400" dirty="0"/>
-          </a:p>
-          <a:p>
-            <a:pPr indent="0" marL="0">
-              <a:lnSpc>
-                <a:spcPts val="2200"/>
-              </a:lnSpc>
-              <a:buNone/>
-            </a:pPr>
-            <a:r>
-              <a:rPr lang="en-US" sz="1400" dirty="0">
-                <a:solidFill>
-                  <a:srgbClr val="1A1A1A"/>
-                </a:solidFill>
-              </a:rPr>
-              <a:t>Log into Toddle and confirm you can see the Design 1 class.</a:t>
+              <a:t>Let's see where the room is at.</a:t>
             </a:r>
             <a:endParaRPr lang="en-US" sz="1400" dirty="0"/>
           </a:p>
@@ -3929,7 +4657,7 @@
                   <a:srgbClr val="CFE8F2"/>
                 </a:solidFill>
               </a:rPr>
-              <a:t>2 / 3</a:t>
+              <a:t>1 / 3</a:t>
             </a:r>
             <a:endParaRPr lang="en-US" sz="1000" dirty="0"/>
           </a:p>
@@ -3969,7 +4697,7 @@
         <p:spPr>
           <a:xfrm>
             <a:off x="2880360" y="1280160"/>
-            <a:ext cx="5852160" cy="2976372"/>
+            <a:ext cx="2743200" cy="2976372"/>
           </a:xfrm>
           <a:prstGeom prst="rect">
             <a:avLst/>
@@ -3994,7 +4722,7 @@
                   <a:srgbClr val="1A1A1A"/>
                 </a:solidFill>
               </a:rPr>
-              <a:t>Setting Up Your Tools</a:t>
+              <a:t>Getting Connected</a:t>
             </a:r>
             <a:endParaRPr lang="en-US" sz="1400" dirty="0"/>
           </a:p>
@@ -4011,7 +4739,7 @@
                   <a:srgbClr val="1A1A1A"/>
                 </a:solidFill>
               </a:rPr>
-              <a:t>Locate and verify your code editor (VS Code or Notepad).</a:t>
+              <a:t>Log into your laptop and check the school network.</a:t>
             </a:r>
             <a:endParaRPr lang="en-US" sz="1400" dirty="0"/>
           </a:p>
@@ -4028,26 +4756,100 @@
                   <a:srgbClr val="1A1A1A"/>
                 </a:solidFill>
               </a:rPr>
-              <a:t>Set up a class folder on your desktop or OneDrive, for example Design1-HTML.</a:t>
+              <a:t>Log into Toddle and confirm you can see the Design 1 class.</a:t>
             </a:r>
             <a:endParaRPr lang="en-US" sz="1400" dirty="0"/>
           </a:p>
-          <a:p>
-            <a:pPr indent="0" marL="0">
-              <a:lnSpc>
-                <a:spcPts val="2200"/>
-              </a:lnSpc>
+        </p:txBody>
+      </p:sp>
+      <p:sp>
+        <p:nvSpPr>
+          <p:cNvPr id="12" name="Shape 8"/>
+          <p:cNvSpPr/>
+          <p:nvPr/>
+        </p:nvSpPr>
+        <p:spPr>
+          <a:xfrm>
+            <a:off x="5888736" y="1243584"/>
+            <a:ext cx="2933395" cy="3049524"/>
+          </a:xfrm>
+          <a:prstGeom prst="rect">
+            <a:avLst/>
+          </a:prstGeom>
+          <a:solidFill>
+            <a:srgbClr val="FFFFFF"/>
+          </a:solidFill>
+          <a:ln w="12700">
+            <a:solidFill>
+              <a:srgbClr val="D8E4EB"/>
+            </a:solidFill>
+            <a:prstDash val="solid"/>
+          </a:ln>
+          <a:effectLst>
+            <a:outerShdw sx="100000" sy="100000" kx="0" ky="0" algn="bl" rotWithShape="0" blurRad="76200" dist="25400" dir="5400000">
+              <a:srgbClr val="000000">
+                <a:alpha val="25000"/>
+              </a:srgbClr>
+            </a:outerShdw>
+          </a:effectLst>
+        </p:spPr>
+      </p:sp>
+      <p:pic>
+        <p:nvPicPr>
+          <p:cNvPr id="13" name="Image 2" descr="C:\Users\a.abboud\AppData\Local\Temp\g9_week1_slides_v3\w1l2_activity.png">    </p:cNvPr>
+          <p:cNvPicPr>
+            <a:picLocks noChangeAspect="1"/>
+          </p:cNvPicPr>
+          <p:nvPr/>
+        </p:nvPicPr>
+        <p:blipFill>
+          <a:blip r:embed="rId3"/>
+          <a:srcRect l="0" r="0" t="0" b="0"/>
+          <a:stretch/>
+        </p:blipFill>
+        <p:spPr>
+          <a:xfrm>
+            <a:off x="5925312" y="1280160"/>
+            <a:ext cx="2860243" cy="2793492"/>
+          </a:xfrm>
+          <a:prstGeom prst="rect">
+            <a:avLst/>
+          </a:prstGeom>
+        </p:spPr>
+      </p:pic>
+      <p:sp>
+        <p:nvSpPr>
+          <p:cNvPr id="14" name="Text 9"/>
+          <p:cNvSpPr/>
+          <p:nvPr/>
+        </p:nvSpPr>
+        <p:spPr>
+          <a:xfrm>
+            <a:off x="5925312" y="4119372"/>
+            <a:ext cx="2860243" cy="274320"/>
+          </a:xfrm>
+          <a:prstGeom prst="rect">
+            <a:avLst/>
+          </a:prstGeom>
+          <a:noFill/>
+          <a:ln/>
+        </p:spPr>
+        <p:txBody>
+          <a:bodyPr wrap="square" rtlCol="0" anchor="ctr"/>
+          <a:lstStyle/>
+          <a:p>
+            <a:pPr algn="ctr" indent="0" marL="0">
               <a:buNone/>
             </a:pPr>
             <a:r>
-              <a:rPr lang="en-US" sz="1400" dirty="0">
-                <a:solidFill>
-                  <a:srgbClr val="1A1A1A"/>
-                </a:solidFill>
-              </a:rPr>
-              <a:t>File naming rules: no spaces, all lowercase, correct .html extension.</a:t>
-            </a:r>
-            <a:endParaRPr lang="en-US" sz="1400" dirty="0"/>
+              <a:rPr lang="en-US" sz="900" i="1" dirty="0">
+                <a:solidFill>
+                  <a:srgbClr val="4A5568"/>
+                </a:solidFill>
+              </a:rPr>
+              <a:t>Today's activity: the Platform Setup Checklist</a:t>
+            </a:r>
+            <a:endParaRPr lang="en-US" sz="900" dirty="0"/>
           </a:p>
         </p:txBody>
       </p:sp>
@@ -4319,7 +5121,7 @@
                   <a:srgbClr val="CFE8F2"/>
                 </a:solidFill>
               </a:rPr>
-              <a:t>3 / 3</a:t>
+              <a:t>2 / 3</a:t>
             </a:r>
             <a:endParaRPr lang="en-US" sz="1000" dirty="0"/>
           </a:p>
@@ -4384,7 +5186,7 @@
                   <a:srgbClr val="1A1A1A"/>
                 </a:solidFill>
               </a:rPr>
-              <a:t>Hello World Test</a:t>
+              <a:t>Setting Up Your Tools</a:t>
             </a:r>
             <a:endParaRPr lang="en-US" sz="1400" dirty="0"/>
           </a:p>
@@ -4401,7 +5203,7 @@
                   <a:srgbClr val="1A1A1A"/>
                 </a:solidFill>
               </a:rPr>
-              <a:t>Create a file called index.html with a title and the text "Hello, World!"</a:t>
+              <a:t>Locate and verify your code editor (VS Code or Notepad).</a:t>
             </a:r>
             <a:endParaRPr lang="en-US" sz="1400" dirty="0"/>
           </a:p>
@@ -4418,7 +5220,24 @@
                   <a:srgbClr val="1A1A1A"/>
                 </a:solidFill>
               </a:rPr>
-              <a:t>Save it in your folder, then open it in a browser to check it works.</a:t>
+              <a:t>Set up a class folder on your desktop or OneDrive, for example Design1-HTML.</a:t>
+            </a:r>
+            <a:endParaRPr lang="en-US" sz="1400" dirty="0"/>
+          </a:p>
+          <a:p>
+            <a:pPr indent="0" marL="0">
+              <a:lnSpc>
+                <a:spcPts val="2200"/>
+              </a:lnSpc>
+              <a:buNone/>
+            </a:pPr>
+            <a:r>
+              <a:rPr lang="en-US" sz="1400" dirty="0">
+                <a:solidFill>
+                  <a:srgbClr val="1A1A1A"/>
+                </a:solidFill>
+              </a:rPr>
+              <a:t>File naming rules: no spaces, all lowercase, correct .html extension.</a:t>
             </a:r>
             <a:endParaRPr lang="en-US" sz="1400" dirty="0"/>
           </a:p>
@@ -4519,11 +5338,11 @@
             <a:avLst/>
           </a:prstGeom>
           <a:solidFill>
-            <a:srgbClr val="0F9ED5"/>
+            <a:srgbClr val="0E2841"/>
           </a:solidFill>
           <a:ln w="12700">
             <a:solidFill>
-              <a:srgbClr val="0F9ED5"/>
+              <a:srgbClr val="0E2841"/>
             </a:solidFill>
             <a:prstDash val="solid"/>
           </a:ln>
@@ -4559,7 +5378,7 @@
                   <a:srgbClr val="FFFFFF"/>
                 </a:solidFill>
               </a:rPr>
-              <a:t>CLOSURE</a:t>
+              <a:t>LESSON CORE</a:t>
             </a:r>
             <a:endParaRPr lang="en-US" sz="1600" dirty="0"/>
           </a:p>
@@ -4595,7 +5414,7 @@
                   <a:srgbClr val="CFE8F2"/>
                 </a:solidFill>
               </a:rPr>
-              <a:t>Transition &amp; Extend</a:t>
+              <a:t>Gradual Release of Responsibility</a:t>
             </a:r>
             <a:endParaRPr lang="en-US" sz="1100" dirty="0"/>
           </a:p>
@@ -4656,7 +5475,7 @@
                   <a:srgbClr val="CFE8F2"/>
                 </a:solidFill>
               </a:rPr>
-              <a:t>5 - 10 minutes</a:t>
+              <a:t>30 - 40 minutes</a:t>
             </a:r>
             <a:endParaRPr lang="en-US" sz="1000" dirty="0"/>
           </a:p>
@@ -4664,7 +5483,43 @@
       </p:sp>
       <p:sp>
         <p:nvSpPr>
-          <p:cNvPr id="9" name="Shape 5"/>
+          <p:cNvPr id="9" name="Text 5"/>
+          <p:cNvSpPr/>
+          <p:nvPr/>
+        </p:nvSpPr>
+        <p:spPr>
+          <a:xfrm>
+            <a:off x="228600" y="4119372"/>
+            <a:ext cx="1920240" cy="320040"/>
+          </a:xfrm>
+          <a:prstGeom prst="rect">
+            <a:avLst/>
+          </a:prstGeom>
+          <a:noFill/>
+          <a:ln/>
+        </p:spPr>
+        <p:txBody>
+          <a:bodyPr wrap="square" rtlCol="0" anchor="ctr"/>
+          <a:lstStyle/>
+          <a:p>
+            <a:pPr algn="ctr" indent="0" marL="0">
+              <a:buNone/>
+            </a:pPr>
+            <a:r>
+              <a:rPr lang="en-US" sz="1000" dirty="0">
+                <a:solidFill>
+                  <a:srgbClr val="CFE8F2"/>
+                </a:solidFill>
+              </a:rPr>
+              <a:t>3 / 3</a:t>
+            </a:r>
+            <a:endParaRPr lang="en-US" sz="1000" dirty="0"/>
+          </a:p>
+        </p:txBody>
+      </p:sp>
+      <p:sp>
+        <p:nvSpPr>
+          <p:cNvPr id="10" name="Shape 6"/>
           <p:cNvSpPr/>
           <p:nvPr/>
         </p:nvSpPr>
@@ -4689,7 +5544,7 @@
       </p:sp>
       <p:sp>
         <p:nvSpPr>
-          <p:cNvPr id="10" name="Text 6"/>
+          <p:cNvPr id="11" name="Text 7"/>
           <p:cNvSpPr/>
           <p:nvPr/>
         </p:nvSpPr>
@@ -4721,7 +5576,7 @@
                   <a:srgbClr val="1A1A1A"/>
                 </a:solidFill>
               </a:rPr>
-              <a:t>Submit your Hello World screenshot or file link on Toddle.</a:t>
+              <a:t>Hello World Test</a:t>
             </a:r>
             <a:endParaRPr lang="en-US" sz="1400" dirty="0"/>
           </a:p>
@@ -4738,7 +5593,24 @@
                   <a:srgbClr val="1A1A1A"/>
                 </a:solidFill>
               </a:rPr>
-              <a:t>This becomes your entry ticket for Lesson 3.</a:t>
+              <a:t>Create a file called index.html with a title and the text "Hello, World!"</a:t>
+            </a:r>
+            <a:endParaRPr lang="en-US" sz="1400" dirty="0"/>
+          </a:p>
+          <a:p>
+            <a:pPr indent="0" marL="0">
+              <a:lnSpc>
+                <a:spcPts val="2200"/>
+              </a:lnSpc>
+              <a:buNone/>
+            </a:pPr>
+            <a:r>
+              <a:rPr lang="en-US" sz="1400" dirty="0">
+                <a:solidFill>
+                  <a:srgbClr val="1A1A1A"/>
+                </a:solidFill>
+              </a:rPr>
+              <a:t>Save it in your folder, then open it in a browser to check it works.</a:t>
             </a:r>
             <a:endParaRPr lang="en-US" sz="1400" dirty="0"/>
           </a:p>

</xml_diff>